<commit_message>
feat(suite): add Email Phishing NLP Analyzer, Live SSL/DNS Inspector, and Quishing QR Scanner
</commit_message>
<xml_diff>
--- a/PhishGuard_AI_Project_Presentation.pptx
+++ b/PhishGuard_AI_Project_Presentation.pptx
@@ -5804,7 +5804,7 @@
               </a:defRPr>
             </a:pPr>
             <a:r>
-              <a:t>What Is Fully Functional (100% Operational)</a:t>
+              <a:t>Multi-Vector Defense Capabilities (100% Operational)</a:t>
             </a:r>
           </a:p>
           <a:p>
@@ -5836,7 +5836,7 @@
               </a:defRPr>
             </a:pPr>
             <a:r>
-              <a:t>•  Real-Time API: Flask microservice serving sub-15ms predictions and dynamic model metrics.</a:t>
+              <a:t>•  Email &amp; SMS NLP Analyzer: Detects social engineering urgency, fear, coercion &amp; scans embedded links.</a:t>
             </a:r>
           </a:p>
           <a:p>
@@ -5852,7 +5852,7 @@
               </a:defRPr>
             </a:pPr>
             <a:r>
-              <a:t>•  Accurate Lexical Extractor: 17 feature extractors with zero parity mismatch against benchmark.</a:t>
+              <a:t>•  Live SSL / DNS Inspector: Cryptographic X.509 cert validation, TLS 1.3 verification, &amp; CNS Grade A+ to F.</a:t>
             </a:r>
           </a:p>
           <a:p>
@@ -5868,7 +5868,7 @@
               </a:defRPr>
             </a:pPr>
             <a:r>
-              <a:t>•  Cyber Command Center UI: Responsive frontend with radar scanner, SVG gauge, and export.</a:t>
+              <a:t>•  Quishing (QR) Detector: OpenCV computer vision decodes QR codes and pipes payloads to RF model.</a:t>
             </a:r>
           </a:p>
           <a:p>
@@ -5884,7 +5884,7 @@
               </a:defRPr>
             </a:pPr>
             <a:r>
-              <a:t>•  Session History Logger: Automatically logs recent inspections with 1-click re-test.</a:t>
+              <a:t>•  Cyber Command Center UI: Responsive 4-tab security suite with SVG risk dial and radar scanner.</a:t>
             </a:r>
           </a:p>
           <a:p>
@@ -6000,7 +6000,7 @@
               </a:defRPr>
             </a:pPr>
             <a:r>
-              <a:t>•  Clean Project Architecture: Modular separation between backend, frontend, and data directories.</a:t>
+              <a:t>•  Clean Modular Architecture: email_analyzer.py, ssl_dns_inspector.py, qr_scanner.py, app.py.</a:t>
             </a:r>
           </a:p>
           <a:p>
@@ -6032,7 +6032,7 @@
               </a:defRPr>
             </a:pPr>
             <a:r>
-              <a:t>•  Git Version Control: Working branch shantanu-changes pushed to GitHub with tag ui-and-accuracy.</a:t>
+              <a:t>•  Zero External Paid APIs: Entire system runs locally using scikit-learn, OpenCV, Pillow, and Python sockets.</a:t>
             </a:r>
           </a:p>
           <a:p>
@@ -6048,7 +6048,7 @@
               </a:defRPr>
             </a:pPr>
             <a:r>
-              <a:t>•  Zero Memory Leak: Efficient lightweight inference suitable for edge deployment or cloud hosting.</a:t>
+              <a:t>•  Git Version Control: Clean branches and tags (shantanu-changes branch, ui-and-accuracy tag).</a:t>
             </a:r>
           </a:p>
           <a:p>

</xml_diff>